<commit_message>
Adds visualizations and powerpoint slides
</commit_message>
<xml_diff>
--- a/Face Reconition Presentation_v2.pptx
+++ b/Face Reconition Presentation_v2.pptx
@@ -7,6 +7,18 @@
   <p:sldIdLst>
     <p:sldId id="256" r:id="rId2"/>
     <p:sldId id="257" r:id="rId3"/>
+    <p:sldId id="258" r:id="rId4"/>
+    <p:sldId id="259" r:id="rId5"/>
+    <p:sldId id="260" r:id="rId6"/>
+    <p:sldId id="261" r:id="rId7"/>
+    <p:sldId id="262" r:id="rId8"/>
+    <p:sldId id="263" r:id="rId9"/>
+    <p:sldId id="264" r:id="rId10"/>
+    <p:sldId id="265" r:id="rId11"/>
+    <p:sldId id="266" r:id="rId12"/>
+    <p:sldId id="267" r:id="rId13"/>
+    <p:sldId id="268" r:id="rId14"/>
+    <p:sldId id="269" r:id="rId15"/>
   </p:sldIdLst>
   <p:sldSz cx="12192000" cy="6858000"/>
   <p:notesSz cx="6858000" cy="9144000"/>
@@ -105,7 +117,286 @@
       </a:defRPr>
     </a:lvl9pPr>
   </p:defaultTextStyle>
+  <p:extLst>
+    <p:ext uri="{EFAFB233-063F-42B5-8137-9DF3F51BA10A}">
+      <p15:sldGuideLst xmlns:p15="http://schemas.microsoft.com/office/powerpoint/2012/main"/>
+    </p:ext>
+  </p:extLst>
 </p:presentation>
+</file>
+
+<file path=ppt/revisionInfo.xml><?xml version="1.0" encoding="utf-8"?>
+<p1510:revInfo xmlns:a="http://schemas.openxmlformats.org/drawingml/2006/main" xmlns:r="http://schemas.openxmlformats.org/officeDocument/2006/relationships" xmlns:p1510="http://schemas.microsoft.com/office/powerpoint/2015/10/main">
+  <p1510:revLst>
+    <p1510:client id="{47809704-D555-43E9-8763-C18ABFFD866A}" v="15" dt="2025-06-28T00:09:24.259"/>
+  </p1510:revLst>
+</p1510:revInfo>
+</file>
+
+<file path=ppt/changesInfos/changesInfo1.xml><?xml version="1.0" encoding="utf-8"?>
+<pc:chgInfo xmlns:a="http://schemas.openxmlformats.org/drawingml/2006/main" xmlns:r="http://schemas.openxmlformats.org/officeDocument/2006/relationships" xmlns:ac="http://schemas.microsoft.com/office/drawing/2013/main/command" xmlns:pc="http://schemas.microsoft.com/office/powerpoint/2013/main/command">
+  <pc:docChgLst>
+    <pc:chgData name="Cervan Canton Alvaro W.MSCIDS_F24.2301" userId="09644743-1044-4338-95c6-f7c68461d1d3" providerId="ADAL" clId="{47809704-D555-43E9-8763-C18ABFFD866A}"/>
+    <pc:docChg chg="undo redo custSel addSld modSld">
+      <pc:chgData name="Cervan Canton Alvaro W.MSCIDS_F24.2301" userId="09644743-1044-4338-95c6-f7c68461d1d3" providerId="ADAL" clId="{47809704-D555-43E9-8763-C18ABFFD866A}" dt="2025-06-28T00:17:39.580" v="1260" actId="403"/>
+      <pc:docMkLst>
+        <pc:docMk/>
+      </pc:docMkLst>
+      <pc:sldChg chg="modSp new mod">
+        <pc:chgData name="Cervan Canton Alvaro W.MSCIDS_F24.2301" userId="09644743-1044-4338-95c6-f7c68461d1d3" providerId="ADAL" clId="{47809704-D555-43E9-8763-C18ABFFD866A}" dt="2025-06-27T23:52:09.828" v="124"/>
+        <pc:sldMkLst>
+          <pc:docMk/>
+          <pc:sldMk cId="472454260" sldId="258"/>
+        </pc:sldMkLst>
+        <pc:spChg chg="mod">
+          <ac:chgData name="Cervan Canton Alvaro W.MSCIDS_F24.2301" userId="09644743-1044-4338-95c6-f7c68461d1d3" providerId="ADAL" clId="{47809704-D555-43E9-8763-C18ABFFD866A}" dt="2025-06-27T23:48:30.403" v="1"/>
+          <ac:spMkLst>
+            <pc:docMk/>
+            <pc:sldMk cId="472454260" sldId="258"/>
+            <ac:spMk id="2" creationId="{B2DC29F1-C255-9350-4B4B-4E3B2FD0F7CD}"/>
+          </ac:spMkLst>
+        </pc:spChg>
+        <pc:spChg chg="mod">
+          <ac:chgData name="Cervan Canton Alvaro W.MSCIDS_F24.2301" userId="09644743-1044-4338-95c6-f7c68461d1d3" providerId="ADAL" clId="{47809704-D555-43E9-8763-C18ABFFD866A}" dt="2025-06-27T23:52:09.828" v="124"/>
+          <ac:spMkLst>
+            <pc:docMk/>
+            <pc:sldMk cId="472454260" sldId="258"/>
+            <ac:spMk id="3" creationId="{629E353E-726F-2B63-E6D9-F0A5CADFF231}"/>
+          </ac:spMkLst>
+        </pc:spChg>
+      </pc:sldChg>
+      <pc:sldChg chg="modSp new mod">
+        <pc:chgData name="Cervan Canton Alvaro W.MSCIDS_F24.2301" userId="09644743-1044-4338-95c6-f7c68461d1d3" providerId="ADAL" clId="{47809704-D555-43E9-8763-C18ABFFD866A}" dt="2025-06-27T23:57:18.190" v="331" actId="20577"/>
+        <pc:sldMkLst>
+          <pc:docMk/>
+          <pc:sldMk cId="1119096577" sldId="259"/>
+        </pc:sldMkLst>
+        <pc:spChg chg="mod">
+          <ac:chgData name="Cervan Canton Alvaro W.MSCIDS_F24.2301" userId="09644743-1044-4338-95c6-f7c68461d1d3" providerId="ADAL" clId="{47809704-D555-43E9-8763-C18ABFFD866A}" dt="2025-06-27T23:54:53.972" v="158" actId="20577"/>
+          <ac:spMkLst>
+            <pc:docMk/>
+            <pc:sldMk cId="1119096577" sldId="259"/>
+            <ac:spMk id="2" creationId="{3EEA2A6A-7218-6D05-9E39-DAF42C2CBF0E}"/>
+          </ac:spMkLst>
+        </pc:spChg>
+        <pc:spChg chg="mod">
+          <ac:chgData name="Cervan Canton Alvaro W.MSCIDS_F24.2301" userId="09644743-1044-4338-95c6-f7c68461d1d3" providerId="ADAL" clId="{47809704-D555-43E9-8763-C18ABFFD866A}" dt="2025-06-27T23:57:18.190" v="331" actId="20577"/>
+          <ac:spMkLst>
+            <pc:docMk/>
+            <pc:sldMk cId="1119096577" sldId="259"/>
+            <ac:spMk id="3" creationId="{8FAD9094-2680-17EB-C71A-AC4ABAEC2E6E}"/>
+          </ac:spMkLst>
+        </pc:spChg>
+      </pc:sldChg>
+      <pc:sldChg chg="addSp modSp new mod">
+        <pc:chgData name="Cervan Canton Alvaro W.MSCIDS_F24.2301" userId="09644743-1044-4338-95c6-f7c68461d1d3" providerId="ADAL" clId="{47809704-D555-43E9-8763-C18ABFFD866A}" dt="2025-06-28T00:17:39.580" v="1260" actId="403"/>
+        <pc:sldMkLst>
+          <pc:docMk/>
+          <pc:sldMk cId="1625124294" sldId="260"/>
+        </pc:sldMkLst>
+        <pc:spChg chg="mod">
+          <ac:chgData name="Cervan Canton Alvaro W.MSCIDS_F24.2301" userId="09644743-1044-4338-95c6-f7c68461d1d3" providerId="ADAL" clId="{47809704-D555-43E9-8763-C18ABFFD866A}" dt="2025-06-28T00:16:49.823" v="1259" actId="20577"/>
+          <ac:spMkLst>
+            <pc:docMk/>
+            <pc:sldMk cId="1625124294" sldId="260"/>
+            <ac:spMk id="2" creationId="{0B08014F-0FFD-174B-D16F-11B42F948C3A}"/>
+          </ac:spMkLst>
+        </pc:spChg>
+        <pc:spChg chg="mod">
+          <ac:chgData name="Cervan Canton Alvaro W.MSCIDS_F24.2301" userId="09644743-1044-4338-95c6-f7c68461d1d3" providerId="ADAL" clId="{47809704-D555-43E9-8763-C18ABFFD866A}" dt="2025-06-28T00:13:48.521" v="1051" actId="27636"/>
+          <ac:spMkLst>
+            <pc:docMk/>
+            <pc:sldMk cId="1625124294" sldId="260"/>
+            <ac:spMk id="3" creationId="{FFFE5850-A05B-3B23-F736-BB3CE7697F40}"/>
+          </ac:spMkLst>
+        </pc:spChg>
+        <pc:spChg chg="add mod">
+          <ac:chgData name="Cervan Canton Alvaro W.MSCIDS_F24.2301" userId="09644743-1044-4338-95c6-f7c68461d1d3" providerId="ADAL" clId="{47809704-D555-43E9-8763-C18ABFFD866A}" dt="2025-06-28T00:17:39.580" v="1260" actId="403"/>
+          <ac:spMkLst>
+            <pc:docMk/>
+            <pc:sldMk cId="1625124294" sldId="260"/>
+            <ac:spMk id="4" creationId="{BD029C9D-BD38-07FC-9050-8BEFA4DC9291}"/>
+          </ac:spMkLst>
+        </pc:spChg>
+      </pc:sldChg>
+      <pc:sldChg chg="addSp delSp modSp new mod">
+        <pc:chgData name="Cervan Canton Alvaro W.MSCIDS_F24.2301" userId="09644743-1044-4338-95c6-f7c68461d1d3" providerId="ADAL" clId="{47809704-D555-43E9-8763-C18ABFFD866A}" dt="2025-06-28T00:09:43.013" v="944" actId="20577"/>
+        <pc:sldMkLst>
+          <pc:docMk/>
+          <pc:sldMk cId="1435071399" sldId="261"/>
+        </pc:sldMkLst>
+        <pc:spChg chg="mod">
+          <ac:chgData name="Cervan Canton Alvaro W.MSCIDS_F24.2301" userId="09644743-1044-4338-95c6-f7c68461d1d3" providerId="ADAL" clId="{47809704-D555-43E9-8763-C18ABFFD866A}" dt="2025-06-28T00:01:04.132" v="563" actId="20577"/>
+          <ac:spMkLst>
+            <pc:docMk/>
+            <pc:sldMk cId="1435071399" sldId="261"/>
+            <ac:spMk id="2" creationId="{DB1BA345-6744-3FE7-3680-97566F1F098F}"/>
+          </ac:spMkLst>
+        </pc:spChg>
+        <pc:spChg chg="add del mod">
+          <ac:chgData name="Cervan Canton Alvaro W.MSCIDS_F24.2301" userId="09644743-1044-4338-95c6-f7c68461d1d3" providerId="ADAL" clId="{47809704-D555-43E9-8763-C18ABFFD866A}" dt="2025-06-28T00:09:43.013" v="944" actId="20577"/>
+          <ac:spMkLst>
+            <pc:docMk/>
+            <pc:sldMk cId="1435071399" sldId="261"/>
+            <ac:spMk id="3" creationId="{9F5F05AC-DA74-8CF0-9B54-052F1E831274}"/>
+          </ac:spMkLst>
+        </pc:spChg>
+        <pc:spChg chg="add mod">
+          <ac:chgData name="Cervan Canton Alvaro W.MSCIDS_F24.2301" userId="09644743-1044-4338-95c6-f7c68461d1d3" providerId="ADAL" clId="{47809704-D555-43E9-8763-C18ABFFD866A}" dt="2025-06-28T00:01:11.654" v="569"/>
+          <ac:spMkLst>
+            <pc:docMk/>
+            <pc:sldMk cId="1435071399" sldId="261"/>
+            <ac:spMk id="4" creationId="{6D3F985E-C954-2912-8A69-15E8309BFD72}"/>
+          </ac:spMkLst>
+        </pc:spChg>
+        <pc:spChg chg="add del mod">
+          <ac:chgData name="Cervan Canton Alvaro W.MSCIDS_F24.2301" userId="09644743-1044-4338-95c6-f7c68461d1d3" providerId="ADAL" clId="{47809704-D555-43E9-8763-C18ABFFD866A}" dt="2025-06-28T00:08:24.023" v="926" actId="478"/>
+          <ac:spMkLst>
+            <pc:docMk/>
+            <pc:sldMk cId="1435071399" sldId="261"/>
+            <ac:spMk id="5" creationId="{020517F5-A2FC-E2FD-F559-B52A0956D0B0}"/>
+          </ac:spMkLst>
+        </pc:spChg>
+        <pc:spChg chg="add mod">
+          <ac:chgData name="Cervan Canton Alvaro W.MSCIDS_F24.2301" userId="09644743-1044-4338-95c6-f7c68461d1d3" providerId="ADAL" clId="{47809704-D555-43E9-8763-C18ABFFD866A}" dt="2025-06-28T00:08:10.398" v="924"/>
+          <ac:spMkLst>
+            <pc:docMk/>
+            <pc:sldMk cId="1435071399" sldId="261"/>
+            <ac:spMk id="6" creationId="{DD5DA72E-A268-B99E-8040-C1BD30373C7C}"/>
+          </ac:spMkLst>
+        </pc:spChg>
+        <pc:spChg chg="add del">
+          <ac:chgData name="Cervan Canton Alvaro W.MSCIDS_F24.2301" userId="09644743-1044-4338-95c6-f7c68461d1d3" providerId="ADAL" clId="{47809704-D555-43E9-8763-C18ABFFD866A}" dt="2025-06-28T00:09:24.259" v="940" actId="478"/>
+          <ac:spMkLst>
+            <pc:docMk/>
+            <pc:sldMk cId="1435071399" sldId="261"/>
+            <ac:spMk id="7" creationId="{14E9E968-C6FB-0125-3009-A62324C1BF6A}"/>
+          </ac:spMkLst>
+        </pc:spChg>
+      </pc:sldChg>
+      <pc:sldChg chg="modSp new mod">
+        <pc:chgData name="Cervan Canton Alvaro W.MSCIDS_F24.2301" userId="09644743-1044-4338-95c6-f7c68461d1d3" providerId="ADAL" clId="{47809704-D555-43E9-8763-C18ABFFD866A}" dt="2025-06-28T00:10:33.417" v="979" actId="20577"/>
+        <pc:sldMkLst>
+          <pc:docMk/>
+          <pc:sldMk cId="3056003020" sldId="262"/>
+        </pc:sldMkLst>
+        <pc:spChg chg="mod">
+          <ac:chgData name="Cervan Canton Alvaro W.MSCIDS_F24.2301" userId="09644743-1044-4338-95c6-f7c68461d1d3" providerId="ADAL" clId="{47809704-D555-43E9-8763-C18ABFFD866A}" dt="2025-06-28T00:10:33.417" v="979" actId="20577"/>
+          <ac:spMkLst>
+            <pc:docMk/>
+            <pc:sldMk cId="3056003020" sldId="262"/>
+            <ac:spMk id="2" creationId="{ABAA091E-A79B-A64F-5B66-50BDC9382FAC}"/>
+          </ac:spMkLst>
+        </pc:spChg>
+      </pc:sldChg>
+      <pc:sldChg chg="modSp add mod">
+        <pc:chgData name="Cervan Canton Alvaro W.MSCIDS_F24.2301" userId="09644743-1044-4338-95c6-f7c68461d1d3" providerId="ADAL" clId="{47809704-D555-43E9-8763-C18ABFFD866A}" dt="2025-06-28T00:10:43.475" v="983" actId="20577"/>
+        <pc:sldMkLst>
+          <pc:docMk/>
+          <pc:sldMk cId="384888380" sldId="263"/>
+        </pc:sldMkLst>
+        <pc:spChg chg="mod">
+          <ac:chgData name="Cervan Canton Alvaro W.MSCIDS_F24.2301" userId="09644743-1044-4338-95c6-f7c68461d1d3" providerId="ADAL" clId="{47809704-D555-43E9-8763-C18ABFFD866A}" dt="2025-06-28T00:10:43.475" v="983" actId="20577"/>
+          <ac:spMkLst>
+            <pc:docMk/>
+            <pc:sldMk cId="384888380" sldId="263"/>
+            <ac:spMk id="2" creationId="{ABAA091E-A79B-A64F-5B66-50BDC9382FAC}"/>
+          </ac:spMkLst>
+        </pc:spChg>
+      </pc:sldChg>
+      <pc:sldChg chg="modSp add mod">
+        <pc:chgData name="Cervan Canton Alvaro W.MSCIDS_F24.2301" userId="09644743-1044-4338-95c6-f7c68461d1d3" providerId="ADAL" clId="{47809704-D555-43E9-8763-C18ABFFD866A}" dt="2025-06-28T00:11:04.612" v="993" actId="20577"/>
+        <pc:sldMkLst>
+          <pc:docMk/>
+          <pc:sldMk cId="2318978003" sldId="264"/>
+        </pc:sldMkLst>
+        <pc:spChg chg="mod">
+          <ac:chgData name="Cervan Canton Alvaro W.MSCIDS_F24.2301" userId="09644743-1044-4338-95c6-f7c68461d1d3" providerId="ADAL" clId="{47809704-D555-43E9-8763-C18ABFFD866A}" dt="2025-06-28T00:11:04.612" v="993" actId="20577"/>
+          <ac:spMkLst>
+            <pc:docMk/>
+            <pc:sldMk cId="2318978003" sldId="264"/>
+            <ac:spMk id="2" creationId="{ABAA091E-A79B-A64F-5B66-50BDC9382FAC}"/>
+          </ac:spMkLst>
+        </pc:spChg>
+      </pc:sldChg>
+      <pc:sldChg chg="modSp add mod">
+        <pc:chgData name="Cervan Canton Alvaro W.MSCIDS_F24.2301" userId="09644743-1044-4338-95c6-f7c68461d1d3" providerId="ADAL" clId="{47809704-D555-43E9-8763-C18ABFFD866A}" dt="2025-06-28T00:11:18.375" v="995"/>
+        <pc:sldMkLst>
+          <pc:docMk/>
+          <pc:sldMk cId="1001368556" sldId="265"/>
+        </pc:sldMkLst>
+        <pc:spChg chg="mod">
+          <ac:chgData name="Cervan Canton Alvaro W.MSCIDS_F24.2301" userId="09644743-1044-4338-95c6-f7c68461d1d3" providerId="ADAL" clId="{47809704-D555-43E9-8763-C18ABFFD866A}" dt="2025-06-28T00:11:18.375" v="995"/>
+          <ac:spMkLst>
+            <pc:docMk/>
+            <pc:sldMk cId="1001368556" sldId="265"/>
+            <ac:spMk id="2" creationId="{ABAA091E-A79B-A64F-5B66-50BDC9382FAC}"/>
+          </ac:spMkLst>
+        </pc:spChg>
+      </pc:sldChg>
+      <pc:sldChg chg="modSp add mod">
+        <pc:chgData name="Cervan Canton Alvaro W.MSCIDS_F24.2301" userId="09644743-1044-4338-95c6-f7c68461d1d3" providerId="ADAL" clId="{47809704-D555-43E9-8763-C18ABFFD866A}" dt="2025-06-28T00:11:49.216" v="999"/>
+        <pc:sldMkLst>
+          <pc:docMk/>
+          <pc:sldMk cId="631473613" sldId="266"/>
+        </pc:sldMkLst>
+        <pc:spChg chg="mod">
+          <ac:chgData name="Cervan Canton Alvaro W.MSCIDS_F24.2301" userId="09644743-1044-4338-95c6-f7c68461d1d3" providerId="ADAL" clId="{47809704-D555-43E9-8763-C18ABFFD866A}" dt="2025-06-28T00:11:49.216" v="999"/>
+          <ac:spMkLst>
+            <pc:docMk/>
+            <pc:sldMk cId="631473613" sldId="266"/>
+            <ac:spMk id="2" creationId="{ABAA091E-A79B-A64F-5B66-50BDC9382FAC}"/>
+          </ac:spMkLst>
+        </pc:spChg>
+      </pc:sldChg>
+      <pc:sldChg chg="modSp add mod">
+        <pc:chgData name="Cervan Canton Alvaro W.MSCIDS_F24.2301" userId="09644743-1044-4338-95c6-f7c68461d1d3" providerId="ADAL" clId="{47809704-D555-43E9-8763-C18ABFFD866A}" dt="2025-06-28T00:11:57.157" v="1001"/>
+        <pc:sldMkLst>
+          <pc:docMk/>
+          <pc:sldMk cId="984394870" sldId="267"/>
+        </pc:sldMkLst>
+        <pc:spChg chg="mod">
+          <ac:chgData name="Cervan Canton Alvaro W.MSCIDS_F24.2301" userId="09644743-1044-4338-95c6-f7c68461d1d3" providerId="ADAL" clId="{47809704-D555-43E9-8763-C18ABFFD866A}" dt="2025-06-28T00:11:57.157" v="1001"/>
+          <ac:spMkLst>
+            <pc:docMk/>
+            <pc:sldMk cId="984394870" sldId="267"/>
+            <ac:spMk id="2" creationId="{ABAA091E-A79B-A64F-5B66-50BDC9382FAC}"/>
+          </ac:spMkLst>
+        </pc:spChg>
+      </pc:sldChg>
+      <pc:sldChg chg="modSp new mod">
+        <pc:chgData name="Cervan Canton Alvaro W.MSCIDS_F24.2301" userId="09644743-1044-4338-95c6-f7c68461d1d3" providerId="ADAL" clId="{47809704-D555-43E9-8763-C18ABFFD866A}" dt="2025-06-28T00:12:41.479" v="1029" actId="20577"/>
+        <pc:sldMkLst>
+          <pc:docMk/>
+          <pc:sldMk cId="2522694870" sldId="268"/>
+        </pc:sldMkLst>
+        <pc:spChg chg="mod">
+          <ac:chgData name="Cervan Canton Alvaro W.MSCIDS_F24.2301" userId="09644743-1044-4338-95c6-f7c68461d1d3" providerId="ADAL" clId="{47809704-D555-43E9-8763-C18ABFFD866A}" dt="2025-06-28T00:12:41.479" v="1029" actId="20577"/>
+          <ac:spMkLst>
+            <pc:docMk/>
+            <pc:sldMk cId="2522694870" sldId="268"/>
+            <ac:spMk id="2" creationId="{FF365628-049E-9992-49EF-EEE27A6201B2}"/>
+          </ac:spMkLst>
+        </pc:spChg>
+      </pc:sldChg>
+      <pc:sldChg chg="modSp add mod">
+        <pc:chgData name="Cervan Canton Alvaro W.MSCIDS_F24.2301" userId="09644743-1044-4338-95c6-f7c68461d1d3" providerId="ADAL" clId="{47809704-D555-43E9-8763-C18ABFFD866A}" dt="2025-06-28T00:12:52.548" v="1045" actId="20577"/>
+        <pc:sldMkLst>
+          <pc:docMk/>
+          <pc:sldMk cId="253357861" sldId="269"/>
+        </pc:sldMkLst>
+        <pc:spChg chg="mod">
+          <ac:chgData name="Cervan Canton Alvaro W.MSCIDS_F24.2301" userId="09644743-1044-4338-95c6-f7c68461d1d3" providerId="ADAL" clId="{47809704-D555-43E9-8763-C18ABFFD866A}" dt="2025-06-28T00:12:52.548" v="1045" actId="20577"/>
+          <ac:spMkLst>
+            <pc:docMk/>
+            <pc:sldMk cId="253357861" sldId="269"/>
+            <ac:spMk id="2" creationId="{FF365628-049E-9992-49EF-EEE27A6201B2}"/>
+          </ac:spMkLst>
+        </pc:spChg>
+      </pc:sldChg>
+    </pc:docChg>
+  </pc:docChgLst>
+</pc:chgInfo>
 </file>
 
 <file path=ppt/slideLayouts/slideLayout1.xml><?xml version="1.0" encoding="utf-8"?>
@@ -261,7 +552,7 @@
           <a:p>
             <a:fld id="{C128FA71-3A18-48C0-980F-4B68F7F63042}" type="datetime1">
               <a:rPr lang="en-US" smtClean="0"/>
-              <a:t>6/24/2025</a:t>
+              <a:t>6/28/2025</a:t>
             </a:fld>
             <a:endParaRPr lang="en-US"/>
           </a:p>
@@ -469,7 +760,7 @@
           <a:p>
             <a:fld id="{7104EDB3-C0E8-45F8-9E1D-1B6C8D1880C0}" type="datetime1">
               <a:rPr lang="en-US" smtClean="0"/>
-              <a:t>6/24/2025</a:t>
+              <a:t>6/28/2025</a:t>
             </a:fld>
             <a:endParaRPr lang="en-US"/>
           </a:p>
@@ -679,7 +970,7 @@
           <a:p>
             <a:fld id="{9CF0EC4B-54ED-4041-B552-9BA760FA3DBA}" type="datetime1">
               <a:rPr lang="en-US" smtClean="0"/>
-              <a:t>6/24/2025</a:t>
+              <a:t>6/28/2025</a:t>
             </a:fld>
             <a:endParaRPr lang="en-US"/>
           </a:p>
@@ -877,7 +1168,7 @@
           <a:p>
             <a:fld id="{51C1210E-201E-4473-82AC-2466F5386C38}" type="datetime1">
               <a:rPr lang="en-US" smtClean="0"/>
-              <a:t>6/24/2025</a:t>
+              <a:t>6/28/2025</a:t>
             </a:fld>
             <a:endParaRPr lang="en-US"/>
           </a:p>
@@ -1155,7 +1446,7 @@
           <a:p>
             <a:fld id="{B01EA198-6CAB-4B8F-B93F-1F9C8C4B6CE7}" type="datetime1">
               <a:rPr lang="en-US" smtClean="0"/>
-              <a:t>6/24/2025</a:t>
+              <a:t>6/28/2025</a:t>
             </a:fld>
             <a:endParaRPr lang="en-US"/>
           </a:p>
@@ -1427,7 +1718,7 @@
           <a:p>
             <a:fld id="{CA06041F-4525-44D5-AA4F-332294BF1F56}" type="datetime1">
               <a:rPr lang="en-US" smtClean="0"/>
-              <a:t>6/24/2025</a:t>
+              <a:t>6/28/2025</a:t>
             </a:fld>
             <a:endParaRPr lang="en-US"/>
           </a:p>
@@ -1851,7 +2142,7 @@
           <a:p>
             <a:fld id="{F9557091-BBDF-4EB9-BA6B-2BB67AC4FC0F}" type="datetime1">
               <a:rPr lang="en-US" smtClean="0"/>
-              <a:t>6/24/2025</a:t>
+              <a:t>6/28/2025</a:t>
             </a:fld>
             <a:endParaRPr lang="en-US"/>
           </a:p>
@@ -1992,7 +2283,7 @@
           <a:p>
             <a:fld id="{2D6B226B-77A6-410C-9796-083F278E0125}" type="datetime1">
               <a:rPr lang="en-US" smtClean="0"/>
-              <a:t>6/24/2025</a:t>
+              <a:t>6/28/2025</a:t>
             </a:fld>
             <a:endParaRPr lang="en-US"/>
           </a:p>
@@ -2105,7 +2396,7 @@
           <a:p>
             <a:fld id="{A23A578B-D289-4C40-8593-3D356C49DA58}" type="datetime1">
               <a:rPr lang="en-US" smtClean="0"/>
-              <a:t>6/24/2025</a:t>
+              <a:t>6/28/2025</a:t>
             </a:fld>
             <a:endParaRPr lang="en-US"/>
           </a:p>
@@ -2424,7 +2715,7 @@
           <a:p>
             <a:fld id="{713DFAE3-14DB-48A7-A80F-80DDB072CE3D}" type="datetime1">
               <a:rPr lang="en-US" smtClean="0"/>
-              <a:t>6/24/2025</a:t>
+              <a:t>6/28/2025</a:t>
             </a:fld>
             <a:endParaRPr lang="en-US"/>
           </a:p>
@@ -2718,7 +3009,7 @@
           <a:p>
             <a:fld id="{92C5EAEF-6478-4102-8F5D-A5FE9FC97ACB}" type="datetime1">
               <a:rPr lang="en-US" smtClean="0"/>
-              <a:t>6/24/2025</a:t>
+              <a:t>6/28/2025</a:t>
             </a:fld>
             <a:endParaRPr lang="en-US"/>
           </a:p>
@@ -2959,7 +3250,7 @@
           <a:p>
             <a:fld id="{67F45AC6-C491-4585-A584-9CE2AF7D5500}" type="datetime1">
               <a:rPr lang="en-US" smtClean="0"/>
-              <a:t>6/24/2025</a:t>
+              <a:t>6/28/2025</a:t>
             </a:fld>
             <a:endParaRPr lang="en-US"/>
           </a:p>
@@ -3807,6 +4098,480 @@
 </p:sld>
 </file>
 
+<file path=ppt/slides/slide10.xml><?xml version="1.0" encoding="utf-8"?>
+<p:sld xmlns:a="http://schemas.openxmlformats.org/drawingml/2006/main" xmlns:r="http://schemas.openxmlformats.org/officeDocument/2006/relationships" xmlns:p="http://schemas.openxmlformats.org/presentationml/2006/main">
+  <p:cSld>
+    <p:spTree>
+      <p:nvGrpSpPr>
+        <p:cNvPr id="1" name=""/>
+        <p:cNvGrpSpPr/>
+        <p:nvPr/>
+      </p:nvGrpSpPr>
+      <p:grpSpPr>
+        <a:xfrm>
+          <a:off x="0" y="0"/>
+          <a:ext cx="0" cy="0"/>
+          <a:chOff x="0" y="0"/>
+          <a:chExt cx="0" cy="0"/>
+        </a:xfrm>
+      </p:grpSpPr>
+      <p:sp>
+        <p:nvSpPr>
+          <p:cNvPr id="2" name="Title 1">
+            <a:extLst>
+              <a:ext uri="{FF2B5EF4-FFF2-40B4-BE49-F238E27FC236}">
+                <a16:creationId xmlns:a16="http://schemas.microsoft.com/office/drawing/2014/main" id="{ABAA091E-A79B-A64F-5B66-50BDC9382FAC}"/>
+              </a:ext>
+            </a:extLst>
+          </p:cNvPr>
+          <p:cNvSpPr>
+            <a:spLocks noGrp="1"/>
+          </p:cNvSpPr>
+          <p:nvPr>
+            <p:ph type="title"/>
+          </p:nvPr>
+        </p:nvSpPr>
+        <p:spPr/>
+        <p:txBody>
+          <a:bodyPr/>
+          <a:lstStyle/>
+          <a:p>
+            <a:r>
+              <a:rPr lang="es-ES" dirty="0" err="1"/>
+              <a:t>Models</a:t>
+            </a:r>
+            <a:r>
+              <a:rPr lang="es-ES" dirty="0"/>
+              <a:t>: Transfer Learning – MobileNetV2</a:t>
+            </a:r>
+          </a:p>
+        </p:txBody>
+      </p:sp>
+      <p:sp>
+        <p:nvSpPr>
+          <p:cNvPr id="3" name="Content Placeholder 2">
+            <a:extLst>
+              <a:ext uri="{FF2B5EF4-FFF2-40B4-BE49-F238E27FC236}">
+                <a16:creationId xmlns:a16="http://schemas.microsoft.com/office/drawing/2014/main" id="{E60DA390-2E8B-082C-7D4C-CC5FE49679EE}"/>
+              </a:ext>
+            </a:extLst>
+          </p:cNvPr>
+          <p:cNvSpPr>
+            <a:spLocks noGrp="1"/>
+          </p:cNvSpPr>
+          <p:nvPr>
+            <p:ph idx="1"/>
+          </p:nvPr>
+        </p:nvSpPr>
+        <p:spPr/>
+        <p:txBody>
+          <a:bodyPr/>
+          <a:lstStyle/>
+          <a:p>
+            <a:endParaRPr lang="es-ES"/>
+          </a:p>
+        </p:txBody>
+      </p:sp>
+    </p:spTree>
+    <p:extLst>
+      <p:ext uri="{BB962C8B-B14F-4D97-AF65-F5344CB8AC3E}">
+        <p14:creationId xmlns:p14="http://schemas.microsoft.com/office/powerpoint/2010/main" val="1001368556"/>
+      </p:ext>
+    </p:extLst>
+  </p:cSld>
+  <p:clrMapOvr>
+    <a:masterClrMapping/>
+  </p:clrMapOvr>
+</p:sld>
+</file>
+
+<file path=ppt/slides/slide11.xml><?xml version="1.0" encoding="utf-8"?>
+<p:sld xmlns:a="http://schemas.openxmlformats.org/drawingml/2006/main" xmlns:r="http://schemas.openxmlformats.org/officeDocument/2006/relationships" xmlns:p="http://schemas.openxmlformats.org/presentationml/2006/main">
+  <p:cSld>
+    <p:spTree>
+      <p:nvGrpSpPr>
+        <p:cNvPr id="1" name=""/>
+        <p:cNvGrpSpPr/>
+        <p:nvPr/>
+      </p:nvGrpSpPr>
+      <p:grpSpPr>
+        <a:xfrm>
+          <a:off x="0" y="0"/>
+          <a:ext cx="0" cy="0"/>
+          <a:chOff x="0" y="0"/>
+          <a:chExt cx="0" cy="0"/>
+        </a:xfrm>
+      </p:grpSpPr>
+      <p:sp>
+        <p:nvSpPr>
+          <p:cNvPr id="2" name="Title 1">
+            <a:extLst>
+              <a:ext uri="{FF2B5EF4-FFF2-40B4-BE49-F238E27FC236}">
+                <a16:creationId xmlns:a16="http://schemas.microsoft.com/office/drawing/2014/main" id="{ABAA091E-A79B-A64F-5B66-50BDC9382FAC}"/>
+              </a:ext>
+            </a:extLst>
+          </p:cNvPr>
+          <p:cNvSpPr>
+            <a:spLocks noGrp="1"/>
+          </p:cNvSpPr>
+          <p:nvPr>
+            <p:ph type="title"/>
+          </p:nvPr>
+        </p:nvSpPr>
+        <p:spPr/>
+        <p:txBody>
+          <a:bodyPr/>
+          <a:lstStyle/>
+          <a:p>
+            <a:r>
+              <a:rPr lang="es-ES" dirty="0" err="1"/>
+              <a:t>Models</a:t>
+            </a:r>
+            <a:r>
+              <a:rPr lang="es-ES" dirty="0"/>
+              <a:t>: </a:t>
+            </a:r>
+            <a:r>
+              <a:rPr lang="es-ES" dirty="0" err="1"/>
+              <a:t>Embedding-Based</a:t>
+            </a:r>
+            <a:r>
+              <a:rPr lang="es-ES" dirty="0"/>
+              <a:t> – </a:t>
+            </a:r>
+            <a:r>
+              <a:rPr lang="es-ES" dirty="0" err="1"/>
+              <a:t>FaceNet</a:t>
+            </a:r>
+            <a:endParaRPr lang="es-ES" dirty="0"/>
+          </a:p>
+        </p:txBody>
+      </p:sp>
+      <p:sp>
+        <p:nvSpPr>
+          <p:cNvPr id="3" name="Content Placeholder 2">
+            <a:extLst>
+              <a:ext uri="{FF2B5EF4-FFF2-40B4-BE49-F238E27FC236}">
+                <a16:creationId xmlns:a16="http://schemas.microsoft.com/office/drawing/2014/main" id="{E60DA390-2E8B-082C-7D4C-CC5FE49679EE}"/>
+              </a:ext>
+            </a:extLst>
+          </p:cNvPr>
+          <p:cNvSpPr>
+            <a:spLocks noGrp="1"/>
+          </p:cNvSpPr>
+          <p:nvPr>
+            <p:ph idx="1"/>
+          </p:nvPr>
+        </p:nvSpPr>
+        <p:spPr/>
+        <p:txBody>
+          <a:bodyPr/>
+          <a:lstStyle/>
+          <a:p>
+            <a:endParaRPr lang="es-ES"/>
+          </a:p>
+        </p:txBody>
+      </p:sp>
+    </p:spTree>
+    <p:extLst>
+      <p:ext uri="{BB962C8B-B14F-4D97-AF65-F5344CB8AC3E}">
+        <p14:creationId xmlns:p14="http://schemas.microsoft.com/office/powerpoint/2010/main" val="631473613"/>
+      </p:ext>
+    </p:extLst>
+  </p:cSld>
+  <p:clrMapOvr>
+    <a:masterClrMapping/>
+  </p:clrMapOvr>
+</p:sld>
+</file>
+
+<file path=ppt/slides/slide12.xml><?xml version="1.0" encoding="utf-8"?>
+<p:sld xmlns:a="http://schemas.openxmlformats.org/drawingml/2006/main" xmlns:r="http://schemas.openxmlformats.org/officeDocument/2006/relationships" xmlns:p="http://schemas.openxmlformats.org/presentationml/2006/main">
+  <p:cSld>
+    <p:spTree>
+      <p:nvGrpSpPr>
+        <p:cNvPr id="1" name=""/>
+        <p:cNvGrpSpPr/>
+        <p:nvPr/>
+      </p:nvGrpSpPr>
+      <p:grpSpPr>
+        <a:xfrm>
+          <a:off x="0" y="0"/>
+          <a:ext cx="0" cy="0"/>
+          <a:chOff x="0" y="0"/>
+          <a:chExt cx="0" cy="0"/>
+        </a:xfrm>
+      </p:grpSpPr>
+      <p:sp>
+        <p:nvSpPr>
+          <p:cNvPr id="2" name="Title 1">
+            <a:extLst>
+              <a:ext uri="{FF2B5EF4-FFF2-40B4-BE49-F238E27FC236}">
+                <a16:creationId xmlns:a16="http://schemas.microsoft.com/office/drawing/2014/main" id="{ABAA091E-A79B-A64F-5B66-50BDC9382FAC}"/>
+              </a:ext>
+            </a:extLst>
+          </p:cNvPr>
+          <p:cNvSpPr>
+            <a:spLocks noGrp="1"/>
+          </p:cNvSpPr>
+          <p:nvPr>
+            <p:ph type="title"/>
+          </p:nvPr>
+        </p:nvSpPr>
+        <p:spPr/>
+        <p:txBody>
+          <a:bodyPr/>
+          <a:lstStyle/>
+          <a:p>
+            <a:r>
+              <a:rPr lang="es-ES" dirty="0" err="1"/>
+              <a:t>Models</a:t>
+            </a:r>
+            <a:r>
+              <a:rPr lang="es-ES" dirty="0"/>
+              <a:t>: </a:t>
+            </a:r>
+            <a:r>
+              <a:rPr lang="es-ES" dirty="0" err="1"/>
+              <a:t>Embedding-Based</a:t>
+            </a:r>
+            <a:r>
+              <a:rPr lang="es-ES" dirty="0"/>
+              <a:t> – </a:t>
+            </a:r>
+            <a:r>
+              <a:rPr lang="es-ES" dirty="0" err="1"/>
+              <a:t>ArcFace</a:t>
+            </a:r>
+            <a:endParaRPr lang="es-ES" dirty="0"/>
+          </a:p>
+        </p:txBody>
+      </p:sp>
+      <p:sp>
+        <p:nvSpPr>
+          <p:cNvPr id="3" name="Content Placeholder 2">
+            <a:extLst>
+              <a:ext uri="{FF2B5EF4-FFF2-40B4-BE49-F238E27FC236}">
+                <a16:creationId xmlns:a16="http://schemas.microsoft.com/office/drawing/2014/main" id="{E60DA390-2E8B-082C-7D4C-CC5FE49679EE}"/>
+              </a:ext>
+            </a:extLst>
+          </p:cNvPr>
+          <p:cNvSpPr>
+            <a:spLocks noGrp="1"/>
+          </p:cNvSpPr>
+          <p:nvPr>
+            <p:ph idx="1"/>
+          </p:nvPr>
+        </p:nvSpPr>
+        <p:spPr/>
+        <p:txBody>
+          <a:bodyPr/>
+          <a:lstStyle/>
+          <a:p>
+            <a:endParaRPr lang="es-ES"/>
+          </a:p>
+        </p:txBody>
+      </p:sp>
+    </p:spTree>
+    <p:extLst>
+      <p:ext uri="{BB962C8B-B14F-4D97-AF65-F5344CB8AC3E}">
+        <p14:creationId xmlns:p14="http://schemas.microsoft.com/office/powerpoint/2010/main" val="984394870"/>
+      </p:ext>
+    </p:extLst>
+  </p:cSld>
+  <p:clrMapOvr>
+    <a:masterClrMapping/>
+  </p:clrMapOvr>
+</p:sld>
+</file>
+
+<file path=ppt/slides/slide13.xml><?xml version="1.0" encoding="utf-8"?>
+<p:sld xmlns:a="http://schemas.openxmlformats.org/drawingml/2006/main" xmlns:r="http://schemas.openxmlformats.org/officeDocument/2006/relationships" xmlns:p="http://schemas.openxmlformats.org/presentationml/2006/main">
+  <p:cSld>
+    <p:spTree>
+      <p:nvGrpSpPr>
+        <p:cNvPr id="1" name=""/>
+        <p:cNvGrpSpPr/>
+        <p:nvPr/>
+      </p:nvGrpSpPr>
+      <p:grpSpPr>
+        <a:xfrm>
+          <a:off x="0" y="0"/>
+          <a:ext cx="0" cy="0"/>
+          <a:chOff x="0" y="0"/>
+          <a:chExt cx="0" cy="0"/>
+        </a:xfrm>
+      </p:grpSpPr>
+      <p:sp>
+        <p:nvSpPr>
+          <p:cNvPr id="2" name="Title 1">
+            <a:extLst>
+              <a:ext uri="{FF2B5EF4-FFF2-40B4-BE49-F238E27FC236}">
+                <a16:creationId xmlns:a16="http://schemas.microsoft.com/office/drawing/2014/main" id="{FF365628-049E-9992-49EF-EEE27A6201B2}"/>
+              </a:ext>
+            </a:extLst>
+          </p:cNvPr>
+          <p:cNvSpPr>
+            <a:spLocks noGrp="1"/>
+          </p:cNvSpPr>
+          <p:nvPr>
+            <p:ph type="title"/>
+          </p:nvPr>
+        </p:nvSpPr>
+        <p:spPr/>
+        <p:txBody>
+          <a:bodyPr/>
+          <a:lstStyle/>
+          <a:p>
+            <a:r>
+              <a:rPr lang="es-ES" dirty="0" err="1"/>
+              <a:t>Evaluation</a:t>
+            </a:r>
+            <a:r>
+              <a:rPr lang="es-ES" dirty="0"/>
+              <a:t> - </a:t>
+            </a:r>
+            <a:r>
+              <a:rPr lang="es-ES" dirty="0" err="1"/>
+              <a:t>Classification</a:t>
+            </a:r>
+            <a:endParaRPr lang="es-ES" dirty="0"/>
+          </a:p>
+        </p:txBody>
+      </p:sp>
+      <p:sp>
+        <p:nvSpPr>
+          <p:cNvPr id="3" name="Content Placeholder 2">
+            <a:extLst>
+              <a:ext uri="{FF2B5EF4-FFF2-40B4-BE49-F238E27FC236}">
+                <a16:creationId xmlns:a16="http://schemas.microsoft.com/office/drawing/2014/main" id="{65518192-0545-B17B-4EA3-4AD08303C051}"/>
+              </a:ext>
+            </a:extLst>
+          </p:cNvPr>
+          <p:cNvSpPr>
+            <a:spLocks noGrp="1"/>
+          </p:cNvSpPr>
+          <p:nvPr>
+            <p:ph idx="1"/>
+          </p:nvPr>
+        </p:nvSpPr>
+        <p:spPr/>
+        <p:txBody>
+          <a:bodyPr/>
+          <a:lstStyle/>
+          <a:p>
+            <a:endParaRPr lang="es-ES"/>
+          </a:p>
+        </p:txBody>
+      </p:sp>
+    </p:spTree>
+    <p:extLst>
+      <p:ext uri="{BB962C8B-B14F-4D97-AF65-F5344CB8AC3E}">
+        <p14:creationId xmlns:p14="http://schemas.microsoft.com/office/powerpoint/2010/main" val="2522694870"/>
+      </p:ext>
+    </p:extLst>
+  </p:cSld>
+  <p:clrMapOvr>
+    <a:masterClrMapping/>
+  </p:clrMapOvr>
+</p:sld>
+</file>
+
+<file path=ppt/slides/slide14.xml><?xml version="1.0" encoding="utf-8"?>
+<p:sld xmlns:a="http://schemas.openxmlformats.org/drawingml/2006/main" xmlns:r="http://schemas.openxmlformats.org/officeDocument/2006/relationships" xmlns:p="http://schemas.openxmlformats.org/presentationml/2006/main">
+  <p:cSld>
+    <p:spTree>
+      <p:nvGrpSpPr>
+        <p:cNvPr id="1" name=""/>
+        <p:cNvGrpSpPr/>
+        <p:nvPr/>
+      </p:nvGrpSpPr>
+      <p:grpSpPr>
+        <a:xfrm>
+          <a:off x="0" y="0"/>
+          <a:ext cx="0" cy="0"/>
+          <a:chOff x="0" y="0"/>
+          <a:chExt cx="0" cy="0"/>
+        </a:xfrm>
+      </p:grpSpPr>
+      <p:sp>
+        <p:nvSpPr>
+          <p:cNvPr id="2" name="Title 1">
+            <a:extLst>
+              <a:ext uri="{FF2B5EF4-FFF2-40B4-BE49-F238E27FC236}">
+                <a16:creationId xmlns:a16="http://schemas.microsoft.com/office/drawing/2014/main" id="{FF365628-049E-9992-49EF-EEE27A6201B2}"/>
+              </a:ext>
+            </a:extLst>
+          </p:cNvPr>
+          <p:cNvSpPr>
+            <a:spLocks noGrp="1"/>
+          </p:cNvSpPr>
+          <p:nvPr>
+            <p:ph type="title"/>
+          </p:nvPr>
+        </p:nvSpPr>
+        <p:spPr/>
+        <p:txBody>
+          <a:bodyPr/>
+          <a:lstStyle/>
+          <a:p>
+            <a:r>
+              <a:rPr lang="es-ES" dirty="0" err="1"/>
+              <a:t>Evaluation</a:t>
+            </a:r>
+            <a:r>
+              <a:rPr lang="es-ES" dirty="0"/>
+              <a:t> – </a:t>
+            </a:r>
+            <a:r>
+              <a:rPr lang="es-ES" dirty="0" err="1"/>
+              <a:t>Validation</a:t>
+            </a:r>
+            <a:r>
+              <a:rPr lang="es-ES" dirty="0"/>
+              <a:t> 1:1</a:t>
+            </a:r>
+          </a:p>
+        </p:txBody>
+      </p:sp>
+      <p:sp>
+        <p:nvSpPr>
+          <p:cNvPr id="3" name="Content Placeholder 2">
+            <a:extLst>
+              <a:ext uri="{FF2B5EF4-FFF2-40B4-BE49-F238E27FC236}">
+                <a16:creationId xmlns:a16="http://schemas.microsoft.com/office/drawing/2014/main" id="{65518192-0545-B17B-4EA3-4AD08303C051}"/>
+              </a:ext>
+            </a:extLst>
+          </p:cNvPr>
+          <p:cNvSpPr>
+            <a:spLocks noGrp="1"/>
+          </p:cNvSpPr>
+          <p:nvPr>
+            <p:ph idx="1"/>
+          </p:nvPr>
+        </p:nvSpPr>
+        <p:spPr/>
+        <p:txBody>
+          <a:bodyPr/>
+          <a:lstStyle/>
+          <a:p>
+            <a:endParaRPr lang="es-ES" dirty="0"/>
+          </a:p>
+        </p:txBody>
+      </p:sp>
+    </p:spTree>
+    <p:extLst>
+      <p:ext uri="{BB962C8B-B14F-4D97-AF65-F5344CB8AC3E}">
+        <p14:creationId xmlns:p14="http://schemas.microsoft.com/office/powerpoint/2010/main" val="253357861"/>
+      </p:ext>
+    </p:extLst>
+  </p:cSld>
+  <p:clrMapOvr>
+    <a:masterClrMapping/>
+  </p:clrMapOvr>
+</p:sld>
+</file>
+
 <file path=ppt/slides/slide2.xml><?xml version="1.0" encoding="utf-8"?>
 <p:sld xmlns:a="http://schemas.openxmlformats.org/drawingml/2006/main" xmlns:r="http://schemas.openxmlformats.org/officeDocument/2006/relationships" xmlns:p="http://schemas.openxmlformats.org/presentationml/2006/main">
   <p:cSld>
@@ -4118,6 +4883,1336 @@
     <p:extLst>
       <p:ext uri="{BB962C8B-B14F-4D97-AF65-F5344CB8AC3E}">
         <p14:creationId xmlns:p14="http://schemas.microsoft.com/office/powerpoint/2010/main" val="1294510381"/>
+      </p:ext>
+    </p:extLst>
+  </p:cSld>
+  <p:clrMapOvr>
+    <a:masterClrMapping/>
+  </p:clrMapOvr>
+</p:sld>
+</file>
+
+<file path=ppt/slides/slide3.xml><?xml version="1.0" encoding="utf-8"?>
+<p:sld xmlns:a="http://schemas.openxmlformats.org/drawingml/2006/main" xmlns:r="http://schemas.openxmlformats.org/officeDocument/2006/relationships" xmlns:p="http://schemas.openxmlformats.org/presentationml/2006/main">
+  <p:cSld>
+    <p:spTree>
+      <p:nvGrpSpPr>
+        <p:cNvPr id="1" name=""/>
+        <p:cNvGrpSpPr/>
+        <p:nvPr/>
+      </p:nvGrpSpPr>
+      <p:grpSpPr>
+        <a:xfrm>
+          <a:off x="0" y="0"/>
+          <a:ext cx="0" cy="0"/>
+          <a:chOff x="0" y="0"/>
+          <a:chExt cx="0" cy="0"/>
+        </a:xfrm>
+      </p:grpSpPr>
+      <p:sp>
+        <p:nvSpPr>
+          <p:cNvPr id="2" name="Title 1">
+            <a:extLst>
+              <a:ext uri="{FF2B5EF4-FFF2-40B4-BE49-F238E27FC236}">
+                <a16:creationId xmlns:a16="http://schemas.microsoft.com/office/drawing/2014/main" id="{B2DC29F1-C255-9350-4B4B-4E3B2FD0F7CD}"/>
+              </a:ext>
+            </a:extLst>
+          </p:cNvPr>
+          <p:cNvSpPr>
+            <a:spLocks noGrp="1"/>
+          </p:cNvSpPr>
+          <p:nvPr>
+            <p:ph type="title"/>
+          </p:nvPr>
+        </p:nvSpPr>
+        <p:spPr/>
+        <p:txBody>
+          <a:bodyPr/>
+          <a:lstStyle/>
+          <a:p>
+            <a:r>
+              <a:rPr lang="es-ES" dirty="0"/>
+              <a:t>What is </a:t>
+            </a:r>
+            <a:r>
+              <a:rPr lang="es-ES" dirty="0" err="1"/>
+              <a:t>Face</a:t>
+            </a:r>
+            <a:r>
+              <a:rPr lang="es-ES" dirty="0"/>
+              <a:t> </a:t>
+            </a:r>
+            <a:r>
+              <a:rPr lang="es-ES" dirty="0" err="1"/>
+              <a:t>Recognition</a:t>
+            </a:r>
+            <a:r>
+              <a:rPr lang="es-ES" dirty="0"/>
+              <a:t>?</a:t>
+            </a:r>
+          </a:p>
+        </p:txBody>
+      </p:sp>
+      <p:sp>
+        <p:nvSpPr>
+          <p:cNvPr id="3" name="Content Placeholder 2">
+            <a:extLst>
+              <a:ext uri="{FF2B5EF4-FFF2-40B4-BE49-F238E27FC236}">
+                <a16:creationId xmlns:a16="http://schemas.microsoft.com/office/drawing/2014/main" id="{629E353E-726F-2B63-E6D9-F0A5CADFF231}"/>
+              </a:ext>
+            </a:extLst>
+          </p:cNvPr>
+          <p:cNvSpPr>
+            <a:spLocks noGrp="1"/>
+          </p:cNvSpPr>
+          <p:nvPr>
+            <p:ph idx="1"/>
+          </p:nvPr>
+        </p:nvSpPr>
+        <p:spPr/>
+        <p:txBody>
+          <a:bodyPr/>
+          <a:lstStyle/>
+          <a:p>
+            <a:r>
+              <a:rPr lang="en-US" dirty="0"/>
+              <a:t>Fundamental task in computer vision with diverse applications (device unlock, surveillance, access control, social media tagging).</a:t>
+            </a:r>
+          </a:p>
+          <a:p>
+            <a:r>
+              <a:rPr lang="en-US" dirty="0"/>
+              <a:t>This project focuses on the face detection and comparison between images for security and log-in functions.</a:t>
+            </a:r>
+          </a:p>
+          <a:p>
+            <a:r>
+              <a:rPr lang="en-US" dirty="0"/>
+              <a:t>Deep learning, especially CNNs, has boosted face recognition accuracy by learning robust facial features. These models outperform older methods, even under poor lighting or angle variations.</a:t>
+            </a:r>
+            <a:endParaRPr lang="es-ES" dirty="0"/>
+          </a:p>
+        </p:txBody>
+      </p:sp>
+    </p:spTree>
+    <p:extLst>
+      <p:ext uri="{BB962C8B-B14F-4D97-AF65-F5344CB8AC3E}">
+        <p14:creationId xmlns:p14="http://schemas.microsoft.com/office/powerpoint/2010/main" val="472454260"/>
+      </p:ext>
+    </p:extLst>
+  </p:cSld>
+  <p:clrMapOvr>
+    <a:masterClrMapping/>
+  </p:clrMapOvr>
+</p:sld>
+</file>
+
+<file path=ppt/slides/slide4.xml><?xml version="1.0" encoding="utf-8"?>
+<p:sld xmlns:a="http://schemas.openxmlformats.org/drawingml/2006/main" xmlns:r="http://schemas.openxmlformats.org/officeDocument/2006/relationships" xmlns:p="http://schemas.openxmlformats.org/presentationml/2006/main">
+  <p:cSld>
+    <p:spTree>
+      <p:nvGrpSpPr>
+        <p:cNvPr id="1" name=""/>
+        <p:cNvGrpSpPr/>
+        <p:nvPr/>
+      </p:nvGrpSpPr>
+      <p:grpSpPr>
+        <a:xfrm>
+          <a:off x="0" y="0"/>
+          <a:ext cx="0" cy="0"/>
+          <a:chOff x="0" y="0"/>
+          <a:chExt cx="0" cy="0"/>
+        </a:xfrm>
+      </p:grpSpPr>
+      <p:sp>
+        <p:nvSpPr>
+          <p:cNvPr id="2" name="Title 1">
+            <a:extLst>
+              <a:ext uri="{FF2B5EF4-FFF2-40B4-BE49-F238E27FC236}">
+                <a16:creationId xmlns:a16="http://schemas.microsoft.com/office/drawing/2014/main" id="{3EEA2A6A-7218-6D05-9E39-DAF42C2CBF0E}"/>
+              </a:ext>
+            </a:extLst>
+          </p:cNvPr>
+          <p:cNvSpPr>
+            <a:spLocks noGrp="1"/>
+          </p:cNvSpPr>
+          <p:nvPr>
+            <p:ph type="title"/>
+          </p:nvPr>
+        </p:nvSpPr>
+        <p:spPr/>
+        <p:txBody>
+          <a:bodyPr/>
+          <a:lstStyle/>
+          <a:p>
+            <a:r>
+              <a:rPr lang="es-ES" dirty="0"/>
+              <a:t>Project </a:t>
+            </a:r>
+            <a:r>
+              <a:rPr lang="es-ES" dirty="0" err="1"/>
+              <a:t>Objective</a:t>
+            </a:r>
+            <a:r>
+              <a:rPr lang="es-ES" dirty="0"/>
+              <a:t> and </a:t>
+            </a:r>
+            <a:r>
+              <a:rPr lang="es-ES" dirty="0" err="1"/>
+              <a:t>Motivation</a:t>
+            </a:r>
+            <a:endParaRPr lang="es-ES" dirty="0"/>
+          </a:p>
+        </p:txBody>
+      </p:sp>
+      <p:sp>
+        <p:nvSpPr>
+          <p:cNvPr id="3" name="Content Placeholder 2">
+            <a:extLst>
+              <a:ext uri="{FF2B5EF4-FFF2-40B4-BE49-F238E27FC236}">
+                <a16:creationId xmlns:a16="http://schemas.microsoft.com/office/drawing/2014/main" id="{8FAD9094-2680-17EB-C71A-AC4ABAEC2E6E}"/>
+              </a:ext>
+            </a:extLst>
+          </p:cNvPr>
+          <p:cNvSpPr>
+            <a:spLocks noGrp="1"/>
+          </p:cNvSpPr>
+          <p:nvPr>
+            <p:ph idx="1"/>
+          </p:nvPr>
+        </p:nvSpPr>
+        <p:spPr/>
+        <p:txBody>
+          <a:bodyPr/>
+          <a:lstStyle/>
+          <a:p>
+            <a:r>
+              <a:rPr lang="en-US" b="1" dirty="0"/>
+              <a:t>Objective:</a:t>
+            </a:r>
+            <a:r>
+              <a:rPr lang="en-US" dirty="0"/>
+              <a:t> To evaluate and compare various deep learning models for face classification.</a:t>
+            </a:r>
+            <a:endParaRPr lang="es-ES" dirty="0"/>
+          </a:p>
+          <a:p>
+            <a:r>
+              <a:rPr lang="en-US" b="1" dirty="0"/>
+              <a:t>Dataset:</a:t>
+            </a:r>
+            <a:r>
+              <a:rPr lang="en-US" dirty="0"/>
+              <a:t> Curated dataset of 18 celebrities, about 100 images each.</a:t>
+            </a:r>
+          </a:p>
+          <a:p>
+            <a:r>
+              <a:rPr lang="en-US" b="1" dirty="0"/>
+              <a:t>Goals:</a:t>
+            </a:r>
+            <a:r>
+              <a:rPr lang="en-US" dirty="0"/>
+              <a:t> Understand performance, analyze generalization/overfitting, develop a reproducible evaluation framework.</a:t>
+            </a:r>
+          </a:p>
+          <a:p>
+            <a:r>
+              <a:rPr lang="en-US" b="1" dirty="0"/>
+              <a:t>Why it Matters:</a:t>
+            </a:r>
+            <a:r>
+              <a:rPr lang="en-US" dirty="0"/>
+              <a:t> Insights into transfer learning for smaller datasets, foundational work for resource-constrained deployments.</a:t>
+            </a:r>
+          </a:p>
+          <a:p>
+            <a:r>
+              <a:rPr lang="en-US" b="1" dirty="0"/>
+              <a:t>Question:</a:t>
+            </a:r>
+            <a:r>
+              <a:rPr lang="en-US" dirty="0"/>
+              <a:t> What are the options for less powerful devices like smartphones or laptops to use non-proprietary models and implementations.</a:t>
+            </a:r>
+            <a:endParaRPr lang="es-ES" b="1" dirty="0"/>
+          </a:p>
+        </p:txBody>
+      </p:sp>
+    </p:spTree>
+    <p:extLst>
+      <p:ext uri="{BB962C8B-B14F-4D97-AF65-F5344CB8AC3E}">
+        <p14:creationId xmlns:p14="http://schemas.microsoft.com/office/powerpoint/2010/main" val="1119096577"/>
+      </p:ext>
+    </p:extLst>
+  </p:cSld>
+  <p:clrMapOvr>
+    <a:masterClrMapping/>
+  </p:clrMapOvr>
+</p:sld>
+</file>
+
+<file path=ppt/slides/slide5.xml><?xml version="1.0" encoding="utf-8"?>
+<p:sld xmlns:a="http://schemas.openxmlformats.org/drawingml/2006/main" xmlns:r="http://schemas.openxmlformats.org/officeDocument/2006/relationships" xmlns:p="http://schemas.openxmlformats.org/presentationml/2006/main">
+  <p:cSld>
+    <p:spTree>
+      <p:nvGrpSpPr>
+        <p:cNvPr id="1" name=""/>
+        <p:cNvGrpSpPr/>
+        <p:nvPr/>
+      </p:nvGrpSpPr>
+      <p:grpSpPr>
+        <a:xfrm>
+          <a:off x="0" y="0"/>
+          <a:ext cx="0" cy="0"/>
+          <a:chOff x="0" y="0"/>
+          <a:chExt cx="0" cy="0"/>
+        </a:xfrm>
+      </p:grpSpPr>
+      <p:sp>
+        <p:nvSpPr>
+          <p:cNvPr id="2" name="Title 1">
+            <a:extLst>
+              <a:ext uri="{FF2B5EF4-FFF2-40B4-BE49-F238E27FC236}">
+                <a16:creationId xmlns:a16="http://schemas.microsoft.com/office/drawing/2014/main" id="{0B08014F-0FFD-174B-D16F-11B42F948C3A}"/>
+              </a:ext>
+            </a:extLst>
+          </p:cNvPr>
+          <p:cNvSpPr>
+            <a:spLocks noGrp="1"/>
+          </p:cNvSpPr>
+          <p:nvPr>
+            <p:ph type="title"/>
+          </p:nvPr>
+        </p:nvSpPr>
+        <p:spPr/>
+        <p:txBody>
+          <a:bodyPr/>
+          <a:lstStyle/>
+          <a:p>
+            <a:r>
+              <a:rPr lang="es-ES" dirty="0"/>
+              <a:t>The </a:t>
+            </a:r>
+            <a:r>
+              <a:rPr lang="es-ES" dirty="0" err="1"/>
+              <a:t>Datasets</a:t>
+            </a:r>
+            <a:endParaRPr lang="es-ES" dirty="0"/>
+          </a:p>
+        </p:txBody>
+      </p:sp>
+      <p:sp>
+        <p:nvSpPr>
+          <p:cNvPr id="3" name="Content Placeholder 2">
+            <a:extLst>
+              <a:ext uri="{FF2B5EF4-FFF2-40B4-BE49-F238E27FC236}">
+                <a16:creationId xmlns:a16="http://schemas.microsoft.com/office/drawing/2014/main" id="{FFFE5850-A05B-3B23-F736-BB3CE7697F40}"/>
+              </a:ext>
+            </a:extLst>
+          </p:cNvPr>
+          <p:cNvSpPr>
+            <a:spLocks noGrp="1"/>
+          </p:cNvSpPr>
+          <p:nvPr>
+            <p:ph idx="1"/>
+          </p:nvPr>
+        </p:nvSpPr>
+        <p:spPr>
+          <a:xfrm>
+            <a:off x="612647" y="1715532"/>
+            <a:ext cx="10653579" cy="3992541"/>
+          </a:xfrm>
+        </p:spPr>
+        <p:txBody>
+          <a:bodyPr>
+            <a:normAutofit lnSpcReduction="10000"/>
+          </a:bodyPr>
+          <a:lstStyle/>
+          <a:p>
+            <a:pPr marL="0" indent="0">
+              <a:buNone/>
+            </a:pPr>
+            <a:r>
+              <a:rPr lang="es-ES" sz="2400" b="1" dirty="0"/>
+              <a:t>Original </a:t>
+            </a:r>
+            <a:r>
+              <a:rPr lang="es-ES" sz="2400" b="1" dirty="0" err="1"/>
+              <a:t>Dataset</a:t>
+            </a:r>
+            <a:endParaRPr lang="es-ES" sz="2400" b="1" dirty="0"/>
+          </a:p>
+          <a:p>
+            <a:r>
+              <a:rPr lang="es-ES" dirty="0"/>
+              <a:t>The </a:t>
+            </a:r>
+            <a:r>
+              <a:rPr lang="es-ES" dirty="0" err="1"/>
+              <a:t>dataset</a:t>
+            </a:r>
+            <a:r>
+              <a:rPr lang="es-ES" dirty="0"/>
+              <a:t> </a:t>
+            </a:r>
+            <a:r>
+              <a:rPr lang="es-ES" dirty="0" err="1"/>
+              <a:t>contains</a:t>
+            </a:r>
+            <a:r>
+              <a:rPr lang="es-ES" dirty="0"/>
+              <a:t> 17 </a:t>
+            </a:r>
+            <a:r>
+              <a:rPr lang="es-ES" dirty="0" err="1"/>
+              <a:t>celebrities</a:t>
+            </a:r>
+            <a:r>
+              <a:rPr lang="es-ES" dirty="0"/>
+              <a:t> (100 </a:t>
+            </a:r>
+            <a:r>
+              <a:rPr lang="es-ES" dirty="0" err="1"/>
+              <a:t>images</a:t>
+            </a:r>
+            <a:r>
+              <a:rPr lang="es-ES" dirty="0"/>
+              <a:t> each) </a:t>
+            </a:r>
+            <a:r>
+              <a:rPr lang="es-ES" dirty="0" err="1"/>
+              <a:t>from</a:t>
+            </a:r>
+            <a:r>
+              <a:rPr lang="es-ES" dirty="0"/>
+              <a:t> </a:t>
+            </a:r>
+            <a:r>
+              <a:rPr lang="es-ES" dirty="0" err="1">
+                <a:hlinkClick r:id="rId2"/>
+              </a:rPr>
+              <a:t>kaggle</a:t>
+            </a:r>
+            <a:r>
+              <a:rPr lang="es-ES" dirty="0"/>
+              <a:t> + the </a:t>
+            </a:r>
+            <a:r>
+              <a:rPr lang="es-ES" dirty="0" err="1"/>
+              <a:t>student</a:t>
+            </a:r>
+            <a:r>
+              <a:rPr lang="es-ES" dirty="0"/>
+              <a:t> </a:t>
+            </a:r>
+            <a:r>
+              <a:rPr lang="es-ES" dirty="0" err="1"/>
+              <a:t>images</a:t>
+            </a:r>
+            <a:r>
+              <a:rPr lang="es-ES" dirty="0"/>
+              <a:t> </a:t>
+            </a:r>
+            <a:r>
+              <a:rPr lang="es-ES" dirty="0" err="1"/>
+              <a:t>from</a:t>
+            </a:r>
+            <a:r>
+              <a:rPr lang="es-ES" dirty="0"/>
+              <a:t> a </a:t>
+            </a:r>
+            <a:r>
+              <a:rPr lang="es-ES" dirty="0" err="1"/>
+              <a:t>face</a:t>
+            </a:r>
+            <a:r>
+              <a:rPr lang="es-ES" dirty="0"/>
+              <a:t> </a:t>
+            </a:r>
+            <a:r>
+              <a:rPr lang="es-ES" dirty="0" err="1"/>
+              <a:t>scan</a:t>
+            </a:r>
+            <a:r>
+              <a:rPr lang="es-ES" dirty="0"/>
+              <a:t> video (300 </a:t>
+            </a:r>
+            <a:r>
+              <a:rPr lang="es-ES" dirty="0" err="1"/>
+              <a:t>images</a:t>
+            </a:r>
+            <a:r>
+              <a:rPr lang="es-ES" dirty="0"/>
+              <a:t>), </a:t>
+            </a:r>
+            <a:r>
+              <a:rPr lang="es-ES" dirty="0" err="1"/>
+              <a:t>totalling</a:t>
+            </a:r>
+            <a:r>
+              <a:rPr lang="es-ES" dirty="0"/>
+              <a:t> </a:t>
+            </a:r>
+            <a:r>
+              <a:rPr lang="es-ES" dirty="0" err="1"/>
+              <a:t>around</a:t>
+            </a:r>
+            <a:r>
+              <a:rPr lang="es-ES" dirty="0"/>
+              <a:t> 2000 </a:t>
+            </a:r>
+            <a:r>
+              <a:rPr lang="es-ES" dirty="0" err="1"/>
+              <a:t>images</a:t>
+            </a:r>
+            <a:r>
+              <a:rPr lang="es-ES" dirty="0"/>
+              <a:t>.</a:t>
+            </a:r>
+          </a:p>
+          <a:p>
+            <a:r>
+              <a:rPr lang="es-ES" dirty="0" err="1"/>
+              <a:t>All</a:t>
+            </a:r>
+            <a:r>
+              <a:rPr lang="es-ES" dirty="0"/>
+              <a:t> </a:t>
+            </a:r>
+            <a:r>
+              <a:rPr lang="es-ES" dirty="0" err="1"/>
+              <a:t>images</a:t>
+            </a:r>
+            <a:r>
+              <a:rPr lang="es-ES" dirty="0"/>
+              <a:t> were </a:t>
+            </a:r>
+            <a:r>
+              <a:rPr lang="es-ES" dirty="0" err="1"/>
+              <a:t>pre-processed</a:t>
+            </a:r>
+            <a:r>
+              <a:rPr lang="es-ES" dirty="0"/>
+              <a:t> by using MTCNN </a:t>
+            </a:r>
+            <a:r>
+              <a:rPr lang="es-ES" dirty="0" err="1"/>
+              <a:t>for</a:t>
+            </a:r>
+            <a:r>
+              <a:rPr lang="es-ES" dirty="0"/>
+              <a:t> </a:t>
+            </a:r>
+            <a:r>
+              <a:rPr lang="es-ES" dirty="0" err="1"/>
+              <a:t>face</a:t>
+            </a:r>
+            <a:r>
+              <a:rPr lang="es-ES" dirty="0"/>
+              <a:t> </a:t>
+            </a:r>
+            <a:r>
+              <a:rPr lang="es-ES" dirty="0" err="1"/>
+              <a:t>detection</a:t>
+            </a:r>
+            <a:r>
+              <a:rPr lang="es-ES" dirty="0"/>
+              <a:t>, </a:t>
+            </a:r>
+            <a:r>
+              <a:rPr lang="es-ES" dirty="0" err="1"/>
+              <a:t>resizing</a:t>
+            </a:r>
+            <a:r>
+              <a:rPr lang="es-ES" dirty="0"/>
+              <a:t> and </a:t>
+            </a:r>
+            <a:r>
+              <a:rPr lang="es-ES" dirty="0" err="1"/>
+              <a:t>cropping</a:t>
+            </a:r>
+            <a:r>
+              <a:rPr lang="es-ES" dirty="0"/>
+              <a:t> (128x128) and </a:t>
+            </a:r>
+            <a:r>
+              <a:rPr lang="es-ES" dirty="0" err="1"/>
+              <a:t>normalization</a:t>
+            </a:r>
+            <a:r>
+              <a:rPr lang="es-ES" dirty="0"/>
+              <a:t>.</a:t>
+            </a:r>
+          </a:p>
+          <a:p>
+            <a:pPr marL="0" indent="0">
+              <a:buNone/>
+            </a:pPr>
+            <a:r>
+              <a:rPr lang="es-ES" sz="2400" b="1" dirty="0" err="1"/>
+              <a:t>Augmentation</a:t>
+            </a:r>
+            <a:endParaRPr lang="es-ES" sz="2000" b="1" dirty="0"/>
+          </a:p>
+          <a:p>
+            <a:r>
+              <a:rPr lang="es-ES" dirty="0" err="1"/>
+              <a:t>Images</a:t>
+            </a:r>
+            <a:r>
+              <a:rPr lang="es-ES" dirty="0"/>
+              <a:t> </a:t>
+            </a:r>
+            <a:r>
+              <a:rPr lang="es-ES" dirty="0" err="1"/>
+              <a:t>augmented</a:t>
+            </a:r>
+            <a:r>
+              <a:rPr lang="es-ES" dirty="0"/>
+              <a:t> in 3 different </a:t>
+            </a:r>
+            <a:r>
+              <a:rPr lang="es-ES" dirty="0" err="1"/>
+              <a:t>ways</a:t>
+            </a:r>
+            <a:r>
+              <a:rPr lang="es-ES" dirty="0"/>
+              <a:t>: Horizontal </a:t>
+            </a:r>
+            <a:r>
+              <a:rPr lang="es-ES" dirty="0" err="1"/>
+              <a:t>flip</a:t>
+            </a:r>
+            <a:r>
+              <a:rPr lang="es-ES" dirty="0"/>
+              <a:t>, </a:t>
+            </a:r>
+            <a:r>
+              <a:rPr lang="es-ES" dirty="0" err="1"/>
+              <a:t>slight</a:t>
+            </a:r>
+            <a:r>
+              <a:rPr lang="es-ES" dirty="0"/>
+              <a:t> </a:t>
+            </a:r>
+            <a:r>
+              <a:rPr lang="es-ES" dirty="0" err="1"/>
+              <a:t>rotation</a:t>
+            </a:r>
+            <a:r>
+              <a:rPr lang="es-ES" dirty="0"/>
+              <a:t> and color </a:t>
+            </a:r>
+            <a:r>
+              <a:rPr lang="es-ES" dirty="0" err="1"/>
+              <a:t>jitter</a:t>
+            </a:r>
+            <a:endParaRPr lang="es-ES" dirty="0"/>
+          </a:p>
+          <a:p>
+            <a:r>
+              <a:rPr lang="es-ES" sz="2000" dirty="0"/>
+              <a:t>This </a:t>
+            </a:r>
+            <a:r>
+              <a:rPr lang="es-ES" sz="2000" dirty="0" err="1"/>
+              <a:t>created</a:t>
+            </a:r>
+            <a:r>
+              <a:rPr lang="es-ES" sz="2000" dirty="0"/>
+              <a:t> </a:t>
+            </a:r>
+            <a:r>
+              <a:rPr lang="es-ES" sz="2000" dirty="0" err="1"/>
+              <a:t>for</a:t>
+            </a:r>
+            <a:r>
+              <a:rPr lang="es-ES" sz="2000" dirty="0"/>
+              <a:t> each original </a:t>
+            </a:r>
+            <a:r>
+              <a:rPr lang="es-ES" sz="2000" dirty="0" err="1"/>
+              <a:t>images</a:t>
+            </a:r>
+            <a:r>
+              <a:rPr lang="es-ES" sz="2000" dirty="0"/>
+              <a:t>, 3 extra </a:t>
+            </a:r>
+            <a:r>
+              <a:rPr lang="es-ES" sz="2000" dirty="0" err="1"/>
+              <a:t>augmented</a:t>
+            </a:r>
+            <a:r>
+              <a:rPr lang="es-ES" sz="2000" dirty="0"/>
+              <a:t>, </a:t>
+            </a:r>
+            <a:r>
+              <a:rPr lang="es-ES" sz="2000" dirty="0" err="1"/>
+              <a:t>totalling</a:t>
+            </a:r>
+            <a:r>
+              <a:rPr lang="es-ES" sz="2000" dirty="0"/>
+              <a:t> 2000 x 4 = 8000 </a:t>
+            </a:r>
+            <a:r>
+              <a:rPr lang="es-ES" sz="2000" dirty="0" err="1"/>
+              <a:t>images</a:t>
+            </a:r>
+            <a:endParaRPr lang="es-ES" sz="2000" dirty="0"/>
+          </a:p>
+          <a:p>
+            <a:pPr marL="0" indent="0">
+              <a:buNone/>
+            </a:pPr>
+            <a:endParaRPr lang="es-ES" dirty="0"/>
+          </a:p>
+        </p:txBody>
+      </p:sp>
+      <p:sp>
+        <p:nvSpPr>
+          <p:cNvPr id="4" name="Rectangle: Rounded Corners 3">
+            <a:extLst>
+              <a:ext uri="{FF2B5EF4-FFF2-40B4-BE49-F238E27FC236}">
+                <a16:creationId xmlns:a16="http://schemas.microsoft.com/office/drawing/2014/main" id="{BD029C9D-BD38-07FC-9050-8BEFA4DC9291}"/>
+              </a:ext>
+            </a:extLst>
+          </p:cNvPr>
+          <p:cNvSpPr/>
+          <p:nvPr/>
+        </p:nvSpPr>
+        <p:spPr>
+          <a:xfrm>
+            <a:off x="612648" y="5721927"/>
+            <a:ext cx="10653578" cy="955964"/>
+          </a:xfrm>
+          <a:prstGeom prst="roundRect">
+            <a:avLst/>
+          </a:prstGeom>
+          <a:solidFill>
+            <a:schemeClr val="bg1"/>
+          </a:solidFill>
+          <a:ln w="28575">
+            <a:solidFill>
+              <a:srgbClr val="0070C0"/>
+            </a:solidFill>
+          </a:ln>
+        </p:spPr>
+        <p:style>
+          <a:lnRef idx="2">
+            <a:schemeClr val="accent1">
+              <a:shade val="15000"/>
+            </a:schemeClr>
+          </a:lnRef>
+          <a:fillRef idx="1">
+            <a:schemeClr val="accent1"/>
+          </a:fillRef>
+          <a:effectRef idx="0">
+            <a:schemeClr val="accent1"/>
+          </a:effectRef>
+          <a:fontRef idx="minor">
+            <a:schemeClr val="lt1"/>
+          </a:fontRef>
+        </p:style>
+        <p:txBody>
+          <a:bodyPr rtlCol="0" anchor="ctr"/>
+          <a:lstStyle/>
+          <a:p>
+            <a:pPr algn="ctr"/>
+            <a:r>
+              <a:rPr lang="es-ES" dirty="0">
+                <a:solidFill>
+                  <a:schemeClr val="tx1"/>
+                </a:solidFill>
+              </a:rPr>
+              <a:t>To </a:t>
+            </a:r>
+            <a:r>
+              <a:rPr lang="es-ES" dirty="0" err="1">
+                <a:solidFill>
+                  <a:schemeClr val="tx1"/>
+                </a:solidFill>
+              </a:rPr>
+              <a:t>avoid</a:t>
+            </a:r>
+            <a:r>
+              <a:rPr lang="es-ES" dirty="0">
+                <a:solidFill>
+                  <a:schemeClr val="tx1"/>
+                </a:solidFill>
+              </a:rPr>
+              <a:t> a </a:t>
+            </a:r>
+            <a:r>
+              <a:rPr lang="es-ES" dirty="0" err="1">
+                <a:solidFill>
+                  <a:schemeClr val="tx1"/>
+                </a:solidFill>
+              </a:rPr>
+              <a:t>previous</a:t>
+            </a:r>
+            <a:r>
+              <a:rPr lang="es-ES" dirty="0">
+                <a:solidFill>
+                  <a:schemeClr val="tx1"/>
+                </a:solidFill>
+              </a:rPr>
+              <a:t> </a:t>
+            </a:r>
+            <a:r>
+              <a:rPr lang="es-ES" b="1" dirty="0">
+                <a:solidFill>
+                  <a:schemeClr val="tx1"/>
+                </a:solidFill>
+              </a:rPr>
+              <a:t>data </a:t>
+            </a:r>
+            <a:r>
+              <a:rPr lang="es-ES" b="1" dirty="0" err="1">
+                <a:solidFill>
+                  <a:schemeClr val="tx1"/>
+                </a:solidFill>
+              </a:rPr>
+              <a:t>leakage</a:t>
+            </a:r>
+            <a:r>
+              <a:rPr lang="es-ES" dirty="0">
+                <a:solidFill>
+                  <a:schemeClr val="tx1"/>
+                </a:solidFill>
+              </a:rPr>
+              <a:t>, the Split is done 70% - 15% - 15% in a non-</a:t>
+            </a:r>
+            <a:r>
+              <a:rPr lang="es-ES" dirty="0" err="1">
+                <a:solidFill>
+                  <a:schemeClr val="tx1"/>
+                </a:solidFill>
+              </a:rPr>
+              <a:t>random</a:t>
+            </a:r>
+            <a:r>
+              <a:rPr lang="es-ES" dirty="0">
+                <a:solidFill>
+                  <a:schemeClr val="tx1"/>
+                </a:solidFill>
+              </a:rPr>
+              <a:t> way, </a:t>
+            </a:r>
+            <a:r>
+              <a:rPr lang="es-ES" dirty="0" err="1">
+                <a:solidFill>
+                  <a:schemeClr val="tx1"/>
+                </a:solidFill>
+              </a:rPr>
+              <a:t>making</a:t>
+            </a:r>
+            <a:r>
+              <a:rPr lang="es-ES" dirty="0">
+                <a:solidFill>
+                  <a:schemeClr val="tx1"/>
+                </a:solidFill>
+              </a:rPr>
+              <a:t> </a:t>
+            </a:r>
+            <a:r>
+              <a:rPr lang="es-ES" dirty="0" err="1">
+                <a:solidFill>
+                  <a:schemeClr val="tx1"/>
+                </a:solidFill>
+              </a:rPr>
+              <a:t>deterministic</a:t>
+            </a:r>
+            <a:r>
+              <a:rPr lang="es-ES" dirty="0">
+                <a:solidFill>
+                  <a:schemeClr val="tx1"/>
+                </a:solidFill>
+              </a:rPr>
+              <a:t> and </a:t>
+            </a:r>
+            <a:r>
+              <a:rPr lang="es-ES" dirty="0" err="1">
+                <a:solidFill>
+                  <a:schemeClr val="tx1"/>
+                </a:solidFill>
+              </a:rPr>
+              <a:t>checking</a:t>
+            </a:r>
+            <a:r>
+              <a:rPr lang="es-ES" dirty="0">
+                <a:solidFill>
+                  <a:schemeClr val="tx1"/>
+                </a:solidFill>
+              </a:rPr>
+              <a:t> that </a:t>
+            </a:r>
+            <a:r>
+              <a:rPr lang="es-ES" dirty="0" err="1">
+                <a:solidFill>
+                  <a:schemeClr val="tx1"/>
+                </a:solidFill>
+              </a:rPr>
+              <a:t>all</a:t>
+            </a:r>
+            <a:r>
+              <a:rPr lang="es-ES" dirty="0">
+                <a:solidFill>
+                  <a:schemeClr val="tx1"/>
+                </a:solidFill>
+              </a:rPr>
+              <a:t> 4 </a:t>
+            </a:r>
+            <a:r>
+              <a:rPr lang="es-ES" dirty="0" err="1">
+                <a:solidFill>
+                  <a:schemeClr val="tx1"/>
+                </a:solidFill>
+              </a:rPr>
+              <a:t>images</a:t>
+            </a:r>
+            <a:r>
+              <a:rPr lang="es-ES" dirty="0">
+                <a:solidFill>
+                  <a:schemeClr val="tx1"/>
+                </a:solidFill>
+              </a:rPr>
+              <a:t> (original + 3 </a:t>
+            </a:r>
+            <a:r>
+              <a:rPr lang="es-ES" dirty="0" err="1">
+                <a:solidFill>
+                  <a:schemeClr val="tx1"/>
+                </a:solidFill>
+              </a:rPr>
+              <a:t>augmented</a:t>
+            </a:r>
+            <a:r>
+              <a:rPr lang="es-ES" dirty="0">
+                <a:solidFill>
+                  <a:schemeClr val="tx1"/>
+                </a:solidFill>
+              </a:rPr>
+              <a:t>) were in a single Split.</a:t>
+            </a:r>
+          </a:p>
+        </p:txBody>
+      </p:sp>
+    </p:spTree>
+    <p:extLst>
+      <p:ext uri="{BB962C8B-B14F-4D97-AF65-F5344CB8AC3E}">
+        <p14:creationId xmlns:p14="http://schemas.microsoft.com/office/powerpoint/2010/main" val="1625124294"/>
+      </p:ext>
+    </p:extLst>
+  </p:cSld>
+  <p:clrMapOvr>
+    <a:masterClrMapping/>
+  </p:clrMapOvr>
+</p:sld>
+</file>
+
+<file path=ppt/slides/slide6.xml><?xml version="1.0" encoding="utf-8"?>
+<p:sld xmlns:a="http://schemas.openxmlformats.org/drawingml/2006/main" xmlns:r="http://schemas.openxmlformats.org/officeDocument/2006/relationships" xmlns:p="http://schemas.openxmlformats.org/presentationml/2006/main">
+  <p:cSld>
+    <p:spTree>
+      <p:nvGrpSpPr>
+        <p:cNvPr id="1" name=""/>
+        <p:cNvGrpSpPr/>
+        <p:nvPr/>
+      </p:nvGrpSpPr>
+      <p:grpSpPr>
+        <a:xfrm>
+          <a:off x="0" y="0"/>
+          <a:ext cx="0" cy="0"/>
+          <a:chOff x="0" y="0"/>
+          <a:chExt cx="0" cy="0"/>
+        </a:xfrm>
+      </p:grpSpPr>
+      <p:sp>
+        <p:nvSpPr>
+          <p:cNvPr id="2" name="Title 1">
+            <a:extLst>
+              <a:ext uri="{FF2B5EF4-FFF2-40B4-BE49-F238E27FC236}">
+                <a16:creationId xmlns:a16="http://schemas.microsoft.com/office/drawing/2014/main" id="{DB1BA345-6744-3FE7-3680-97566F1F098F}"/>
+              </a:ext>
+            </a:extLst>
+          </p:cNvPr>
+          <p:cNvSpPr>
+            <a:spLocks noGrp="1"/>
+          </p:cNvSpPr>
+          <p:nvPr>
+            <p:ph type="title"/>
+          </p:nvPr>
+        </p:nvSpPr>
+        <p:spPr/>
+        <p:txBody>
+          <a:bodyPr/>
+          <a:lstStyle/>
+          <a:p>
+            <a:r>
+              <a:rPr lang="es-ES" dirty="0" err="1"/>
+              <a:t>Models</a:t>
+            </a:r>
+            <a:endParaRPr lang="es-ES" dirty="0"/>
+          </a:p>
+        </p:txBody>
+      </p:sp>
+      <p:sp>
+        <p:nvSpPr>
+          <p:cNvPr id="3" name="Content Placeholder 2">
+            <a:extLst>
+              <a:ext uri="{FF2B5EF4-FFF2-40B4-BE49-F238E27FC236}">
+                <a16:creationId xmlns:a16="http://schemas.microsoft.com/office/drawing/2014/main" id="{9F5F05AC-DA74-8CF0-9B54-052F1E831274}"/>
+              </a:ext>
+            </a:extLst>
+          </p:cNvPr>
+          <p:cNvSpPr>
+            <a:spLocks noGrp="1"/>
+          </p:cNvSpPr>
+          <p:nvPr>
+            <p:ph idx="1"/>
+          </p:nvPr>
+        </p:nvSpPr>
+        <p:spPr/>
+        <p:txBody>
+          <a:bodyPr/>
+          <a:lstStyle/>
+          <a:p>
+            <a:r>
+              <a:rPr lang="en-US" dirty="0"/>
+              <a:t>Classical Approaches: PCA, LBP </a:t>
+            </a:r>
+          </a:p>
+          <a:p>
+            <a:r>
+              <a:rPr lang="en-US" dirty="0"/>
+              <a:t>Transfer Learning (CNN Baselines): VGG16 (fine-tuned), MobileNetV2</a:t>
+            </a:r>
+          </a:p>
+          <a:p>
+            <a:r>
+              <a:rPr lang="en-US" dirty="0"/>
+              <a:t>Embedding-Based (State-of-the-Art): </a:t>
+            </a:r>
+            <a:r>
+              <a:rPr lang="en-US" dirty="0" err="1"/>
+              <a:t>FaceNet</a:t>
+            </a:r>
+            <a:r>
+              <a:rPr lang="en-US" dirty="0"/>
+              <a:t>, </a:t>
+            </a:r>
+            <a:r>
+              <a:rPr lang="en-US" dirty="0" err="1"/>
+              <a:t>ArcFace</a:t>
+            </a:r>
+            <a:r>
+              <a:rPr lang="en-US" dirty="0"/>
+              <a:t> (with KNN classifier) </a:t>
+            </a:r>
+          </a:p>
+          <a:p>
+            <a:endParaRPr lang="es-ES" dirty="0"/>
+          </a:p>
+        </p:txBody>
+      </p:sp>
+    </p:spTree>
+    <p:extLst>
+      <p:ext uri="{BB962C8B-B14F-4D97-AF65-F5344CB8AC3E}">
+        <p14:creationId xmlns:p14="http://schemas.microsoft.com/office/powerpoint/2010/main" val="1435071399"/>
+      </p:ext>
+    </p:extLst>
+  </p:cSld>
+  <p:clrMapOvr>
+    <a:masterClrMapping/>
+  </p:clrMapOvr>
+</p:sld>
+</file>
+
+<file path=ppt/slides/slide7.xml><?xml version="1.0" encoding="utf-8"?>
+<p:sld xmlns:a="http://schemas.openxmlformats.org/drawingml/2006/main" xmlns:r="http://schemas.openxmlformats.org/officeDocument/2006/relationships" xmlns:p="http://schemas.openxmlformats.org/presentationml/2006/main">
+  <p:cSld>
+    <p:spTree>
+      <p:nvGrpSpPr>
+        <p:cNvPr id="1" name=""/>
+        <p:cNvGrpSpPr/>
+        <p:nvPr/>
+      </p:nvGrpSpPr>
+      <p:grpSpPr>
+        <a:xfrm>
+          <a:off x="0" y="0"/>
+          <a:ext cx="0" cy="0"/>
+          <a:chOff x="0" y="0"/>
+          <a:chExt cx="0" cy="0"/>
+        </a:xfrm>
+      </p:grpSpPr>
+      <p:sp>
+        <p:nvSpPr>
+          <p:cNvPr id="2" name="Title 1">
+            <a:extLst>
+              <a:ext uri="{FF2B5EF4-FFF2-40B4-BE49-F238E27FC236}">
+                <a16:creationId xmlns:a16="http://schemas.microsoft.com/office/drawing/2014/main" id="{ABAA091E-A79B-A64F-5B66-50BDC9382FAC}"/>
+              </a:ext>
+            </a:extLst>
+          </p:cNvPr>
+          <p:cNvSpPr>
+            <a:spLocks noGrp="1"/>
+          </p:cNvSpPr>
+          <p:nvPr>
+            <p:ph type="title"/>
+          </p:nvPr>
+        </p:nvSpPr>
+        <p:spPr/>
+        <p:txBody>
+          <a:bodyPr/>
+          <a:lstStyle/>
+          <a:p>
+            <a:r>
+              <a:rPr lang="es-ES" dirty="0" err="1"/>
+              <a:t>Models</a:t>
+            </a:r>
+            <a:r>
+              <a:rPr lang="es-ES" dirty="0"/>
+              <a:t>: </a:t>
+            </a:r>
+            <a:r>
+              <a:rPr lang="es-ES" dirty="0" err="1"/>
+              <a:t>Classical</a:t>
+            </a:r>
+            <a:r>
+              <a:rPr lang="es-ES" dirty="0"/>
+              <a:t> </a:t>
+            </a:r>
+            <a:r>
+              <a:rPr lang="es-ES" dirty="0" err="1"/>
+              <a:t>Approaches</a:t>
+            </a:r>
+            <a:r>
+              <a:rPr lang="es-ES" dirty="0"/>
+              <a:t> - PCA</a:t>
+            </a:r>
+          </a:p>
+        </p:txBody>
+      </p:sp>
+      <p:sp>
+        <p:nvSpPr>
+          <p:cNvPr id="3" name="Content Placeholder 2">
+            <a:extLst>
+              <a:ext uri="{FF2B5EF4-FFF2-40B4-BE49-F238E27FC236}">
+                <a16:creationId xmlns:a16="http://schemas.microsoft.com/office/drawing/2014/main" id="{E60DA390-2E8B-082C-7D4C-CC5FE49679EE}"/>
+              </a:ext>
+            </a:extLst>
+          </p:cNvPr>
+          <p:cNvSpPr>
+            <a:spLocks noGrp="1"/>
+          </p:cNvSpPr>
+          <p:nvPr>
+            <p:ph idx="1"/>
+          </p:nvPr>
+        </p:nvSpPr>
+        <p:spPr/>
+        <p:txBody>
+          <a:bodyPr/>
+          <a:lstStyle/>
+          <a:p>
+            <a:endParaRPr lang="es-ES"/>
+          </a:p>
+        </p:txBody>
+      </p:sp>
+    </p:spTree>
+    <p:extLst>
+      <p:ext uri="{BB962C8B-B14F-4D97-AF65-F5344CB8AC3E}">
+        <p14:creationId xmlns:p14="http://schemas.microsoft.com/office/powerpoint/2010/main" val="3056003020"/>
+      </p:ext>
+    </p:extLst>
+  </p:cSld>
+  <p:clrMapOvr>
+    <a:masterClrMapping/>
+  </p:clrMapOvr>
+</p:sld>
+</file>
+
+<file path=ppt/slides/slide8.xml><?xml version="1.0" encoding="utf-8"?>
+<p:sld xmlns:a="http://schemas.openxmlformats.org/drawingml/2006/main" xmlns:r="http://schemas.openxmlformats.org/officeDocument/2006/relationships" xmlns:p="http://schemas.openxmlformats.org/presentationml/2006/main">
+  <p:cSld>
+    <p:spTree>
+      <p:nvGrpSpPr>
+        <p:cNvPr id="1" name=""/>
+        <p:cNvGrpSpPr/>
+        <p:nvPr/>
+      </p:nvGrpSpPr>
+      <p:grpSpPr>
+        <a:xfrm>
+          <a:off x="0" y="0"/>
+          <a:ext cx="0" cy="0"/>
+          <a:chOff x="0" y="0"/>
+          <a:chExt cx="0" cy="0"/>
+        </a:xfrm>
+      </p:grpSpPr>
+      <p:sp>
+        <p:nvSpPr>
+          <p:cNvPr id="2" name="Title 1">
+            <a:extLst>
+              <a:ext uri="{FF2B5EF4-FFF2-40B4-BE49-F238E27FC236}">
+                <a16:creationId xmlns:a16="http://schemas.microsoft.com/office/drawing/2014/main" id="{ABAA091E-A79B-A64F-5B66-50BDC9382FAC}"/>
+              </a:ext>
+            </a:extLst>
+          </p:cNvPr>
+          <p:cNvSpPr>
+            <a:spLocks noGrp="1"/>
+          </p:cNvSpPr>
+          <p:nvPr>
+            <p:ph type="title"/>
+          </p:nvPr>
+        </p:nvSpPr>
+        <p:spPr/>
+        <p:txBody>
+          <a:bodyPr/>
+          <a:lstStyle/>
+          <a:p>
+            <a:r>
+              <a:rPr lang="es-ES" dirty="0" err="1"/>
+              <a:t>Models</a:t>
+            </a:r>
+            <a:r>
+              <a:rPr lang="es-ES" dirty="0"/>
+              <a:t>: </a:t>
+            </a:r>
+            <a:r>
+              <a:rPr lang="es-ES" dirty="0" err="1"/>
+              <a:t>Classical</a:t>
+            </a:r>
+            <a:r>
+              <a:rPr lang="es-ES" dirty="0"/>
+              <a:t> </a:t>
+            </a:r>
+            <a:r>
+              <a:rPr lang="es-ES" dirty="0" err="1"/>
+              <a:t>Approaches</a:t>
+            </a:r>
+            <a:r>
+              <a:rPr lang="es-ES" dirty="0"/>
+              <a:t> - LBP</a:t>
+            </a:r>
+          </a:p>
+        </p:txBody>
+      </p:sp>
+      <p:sp>
+        <p:nvSpPr>
+          <p:cNvPr id="3" name="Content Placeholder 2">
+            <a:extLst>
+              <a:ext uri="{FF2B5EF4-FFF2-40B4-BE49-F238E27FC236}">
+                <a16:creationId xmlns:a16="http://schemas.microsoft.com/office/drawing/2014/main" id="{E60DA390-2E8B-082C-7D4C-CC5FE49679EE}"/>
+              </a:ext>
+            </a:extLst>
+          </p:cNvPr>
+          <p:cNvSpPr>
+            <a:spLocks noGrp="1"/>
+          </p:cNvSpPr>
+          <p:nvPr>
+            <p:ph idx="1"/>
+          </p:nvPr>
+        </p:nvSpPr>
+        <p:spPr/>
+        <p:txBody>
+          <a:bodyPr/>
+          <a:lstStyle/>
+          <a:p>
+            <a:endParaRPr lang="es-ES"/>
+          </a:p>
+        </p:txBody>
+      </p:sp>
+    </p:spTree>
+    <p:extLst>
+      <p:ext uri="{BB962C8B-B14F-4D97-AF65-F5344CB8AC3E}">
+        <p14:creationId xmlns:p14="http://schemas.microsoft.com/office/powerpoint/2010/main" val="384888380"/>
+      </p:ext>
+    </p:extLst>
+  </p:cSld>
+  <p:clrMapOvr>
+    <a:masterClrMapping/>
+  </p:clrMapOvr>
+</p:sld>
+</file>
+
+<file path=ppt/slides/slide9.xml><?xml version="1.0" encoding="utf-8"?>
+<p:sld xmlns:a="http://schemas.openxmlformats.org/drawingml/2006/main" xmlns:r="http://schemas.openxmlformats.org/officeDocument/2006/relationships" xmlns:p="http://schemas.openxmlformats.org/presentationml/2006/main">
+  <p:cSld>
+    <p:spTree>
+      <p:nvGrpSpPr>
+        <p:cNvPr id="1" name=""/>
+        <p:cNvGrpSpPr/>
+        <p:nvPr/>
+      </p:nvGrpSpPr>
+      <p:grpSpPr>
+        <a:xfrm>
+          <a:off x="0" y="0"/>
+          <a:ext cx="0" cy="0"/>
+          <a:chOff x="0" y="0"/>
+          <a:chExt cx="0" cy="0"/>
+        </a:xfrm>
+      </p:grpSpPr>
+      <p:sp>
+        <p:nvSpPr>
+          <p:cNvPr id="2" name="Title 1">
+            <a:extLst>
+              <a:ext uri="{FF2B5EF4-FFF2-40B4-BE49-F238E27FC236}">
+                <a16:creationId xmlns:a16="http://schemas.microsoft.com/office/drawing/2014/main" id="{ABAA091E-A79B-A64F-5B66-50BDC9382FAC}"/>
+              </a:ext>
+            </a:extLst>
+          </p:cNvPr>
+          <p:cNvSpPr>
+            <a:spLocks noGrp="1"/>
+          </p:cNvSpPr>
+          <p:nvPr>
+            <p:ph type="title"/>
+          </p:nvPr>
+        </p:nvSpPr>
+        <p:spPr/>
+        <p:txBody>
+          <a:bodyPr/>
+          <a:lstStyle/>
+          <a:p>
+            <a:r>
+              <a:rPr lang="es-ES" dirty="0" err="1"/>
+              <a:t>Models</a:t>
+            </a:r>
+            <a:r>
+              <a:rPr lang="es-ES" dirty="0"/>
+              <a:t>: Transfer Learning – VGG16</a:t>
+            </a:r>
+          </a:p>
+        </p:txBody>
+      </p:sp>
+      <p:sp>
+        <p:nvSpPr>
+          <p:cNvPr id="3" name="Content Placeholder 2">
+            <a:extLst>
+              <a:ext uri="{FF2B5EF4-FFF2-40B4-BE49-F238E27FC236}">
+                <a16:creationId xmlns:a16="http://schemas.microsoft.com/office/drawing/2014/main" id="{E60DA390-2E8B-082C-7D4C-CC5FE49679EE}"/>
+              </a:ext>
+            </a:extLst>
+          </p:cNvPr>
+          <p:cNvSpPr>
+            <a:spLocks noGrp="1"/>
+          </p:cNvSpPr>
+          <p:nvPr>
+            <p:ph idx="1"/>
+          </p:nvPr>
+        </p:nvSpPr>
+        <p:spPr/>
+        <p:txBody>
+          <a:bodyPr/>
+          <a:lstStyle/>
+          <a:p>
+            <a:endParaRPr lang="es-ES"/>
+          </a:p>
+        </p:txBody>
+      </p:sp>
+    </p:spTree>
+    <p:extLst>
+      <p:ext uri="{BB962C8B-B14F-4D97-AF65-F5344CB8AC3E}">
+        <p14:creationId xmlns:p14="http://schemas.microsoft.com/office/powerpoint/2010/main" val="2318978003"/>
       </p:ext>
     </p:extLst>
   </p:cSld>

</xml_diff>